<commit_message>
补充 Signed-off-by: pppig1357 <2986369349@qq.com>
</commit_message>
<xml_diff>
--- a/Courses/L2 - 交互与判定/L2 课件.pptx
+++ b/Courses/L2 - 交互与判定/L2 课件.pptx
@@ -240,7 +240,7 @@
           <a:p>
             <a:fld id="{E6209F5A-504F-41B5-B45E-D44CC64A4EED}" type="datetimeFigureOut">
               <a:rPr lang="zh-CN" altLang="en-US" smtClean="0"/>
-              <a:t>2026/9/14</a:t>
+              <a:t>2026/9/23</a:t>
             </a:fld>
             <a:endParaRPr lang="zh-CN" altLang="en-US"/>
           </a:p>
@@ -873,7 +873,7 @@
           <a:p>
             <a:fld id="{8312E55A-CB39-4018-9A17-ED285A70921F}" type="datetimeFigureOut">
               <a:rPr lang="zh-CN" altLang="en-US" smtClean="0"/>
-              <a:t>2026/9/14</a:t>
+              <a:t>2026/9/23</a:t>
             </a:fld>
             <a:endParaRPr lang="zh-CN" altLang="en-US"/>
           </a:p>
@@ -1154,7 +1154,7 @@
           <a:p>
             <a:fld id="{8312E55A-CB39-4018-9A17-ED285A70921F}" type="datetimeFigureOut">
               <a:rPr lang="zh-CN" altLang="en-US" smtClean="0"/>
-              <a:t>2026/9/14</a:t>
+              <a:t>2026/9/23</a:t>
             </a:fld>
             <a:endParaRPr lang="zh-CN" altLang="en-US"/>
           </a:p>
@@ -1426,7 +1426,7 @@
           <a:p>
             <a:fld id="{8312E55A-CB39-4018-9A17-ED285A70921F}" type="datetimeFigureOut">
               <a:rPr lang="zh-CN" altLang="en-US" smtClean="0"/>
-              <a:t>2026/9/14</a:t>
+              <a:t>2026/9/23</a:t>
             </a:fld>
             <a:endParaRPr lang="zh-CN" altLang="en-US"/>
           </a:p>
@@ -1808,7 +1808,7 @@
           <a:p>
             <a:fld id="{8312E55A-CB39-4018-9A17-ED285A70921F}" type="datetimeFigureOut">
               <a:rPr lang="zh-CN" altLang="en-US" smtClean="0"/>
-              <a:t>2026/9/14</a:t>
+              <a:t>2026/9/23</a:t>
             </a:fld>
             <a:endParaRPr lang="zh-CN" altLang="en-US"/>
           </a:p>
@@ -2130,7 +2130,7 @@
           <a:p>
             <a:fld id="{8312E55A-CB39-4018-9A17-ED285A70921F}" type="datetimeFigureOut">
               <a:rPr lang="zh-CN" altLang="en-US" smtClean="0"/>
-              <a:t>2026/9/14</a:t>
+              <a:t>2026/9/23</a:t>
             </a:fld>
             <a:endParaRPr lang="zh-CN" altLang="en-US"/>
           </a:p>
@@ -2592,7 +2592,7 @@
           <a:p>
             <a:fld id="{8312E55A-CB39-4018-9A17-ED285A70921F}" type="datetimeFigureOut">
               <a:rPr lang="zh-CN" altLang="en-US" smtClean="0"/>
-              <a:t>2026/9/14</a:t>
+              <a:t>2026/9/23</a:t>
             </a:fld>
             <a:endParaRPr lang="zh-CN" altLang="en-US"/>
           </a:p>
@@ -2768,7 +2768,7 @@
           <a:p>
             <a:fld id="{8312E55A-CB39-4018-9A17-ED285A70921F}" type="datetimeFigureOut">
               <a:rPr lang="zh-CN" altLang="en-US" smtClean="0"/>
-              <a:t>2026/9/14</a:t>
+              <a:t>2026/9/23</a:t>
             </a:fld>
             <a:endParaRPr lang="zh-CN" altLang="en-US"/>
           </a:p>
@@ -2905,7 +2905,7 @@
           <a:p>
             <a:fld id="{8312E55A-CB39-4018-9A17-ED285A70921F}" type="datetimeFigureOut">
               <a:rPr lang="zh-CN" altLang="en-US" smtClean="0"/>
-              <a:t>2026/9/14</a:t>
+              <a:t>2026/9/23</a:t>
             </a:fld>
             <a:endParaRPr lang="zh-CN" altLang="en-US"/>
           </a:p>
@@ -3250,7 +3250,7 @@
           <a:p>
             <a:fld id="{8312E55A-CB39-4018-9A17-ED285A70921F}" type="datetimeFigureOut">
               <a:rPr lang="zh-CN" altLang="en-US" smtClean="0"/>
-              <a:t>2026/9/14</a:t>
+              <a:t>2026/9/23</a:t>
             </a:fld>
             <a:endParaRPr lang="zh-CN" altLang="en-US"/>
           </a:p>
@@ -3460,7 +3460,7 @@
           <a:p>
             <a:fld id="{8312E55A-CB39-4018-9A17-ED285A70921F}" type="datetimeFigureOut">
               <a:rPr lang="zh-CN" altLang="en-US" smtClean="0"/>
-              <a:t>2026/9/14</a:t>
+              <a:t>2026/9/23</a:t>
             </a:fld>
             <a:endParaRPr lang="zh-CN" altLang="en-US"/>
           </a:p>
@@ -3834,7 +3834,7 @@
           <a:p>
             <a:fld id="{8312E55A-CB39-4018-9A17-ED285A70921F}" type="datetimeFigureOut">
               <a:rPr lang="zh-CN" altLang="en-US" smtClean="0"/>
-              <a:t>2026/9/14</a:t>
+              <a:t>2026/9/23</a:t>
             </a:fld>
             <a:endParaRPr lang="zh-CN" altLang="en-US"/>
           </a:p>
@@ -14301,7 +14301,15 @@
             </a:r>
             <a:r>
               <a:rPr lang="zh-CN" altLang="zh-CN" sz="2000" dirty="0"/>
-              <a:t>：_swap_grid_data 先换"真相"（grid 数组 + 每颗宝石记录的 grid_pos），_animate_swap_pair 后播"画面"（屏幕移动）——弹回时也是先换数据再播动画</a:t>
+              <a:t>：_swap_grid_data 先换“</a:t>
+            </a:r>
+            <a:r>
+              <a:rPr lang="zh-CN" altLang="en-US" sz="2000" dirty="0"/>
+              <a:t>实际</a:t>
+            </a:r>
+            <a:r>
+              <a:rPr lang="zh-CN" altLang="zh-CN" sz="2000" dirty="0"/>
+              <a:t>"（grid 数组 + 每颗宝石记录的 grid_pos），_animate_swap_pair 后播"画面"（屏幕移动）——弹回时也是先换数据再播动画</a:t>
             </a:r>
           </a:p>
         </p:txBody>

</xml_diff>